<commit_message>
Agregar datos del autor en portada y simplificar pie de página
Co-Authored-By: Claude Opus 5.5 <noreply@anthropic.com>
Claude-Session: https://claude.ai/code/session_01J3VFP9hTf1Afm8BJZWvQEw
</commit_message>
<xml_diff>
--- a/Caso_Innovatec_ITIL4.pptx
+++ b/Caso_Innovatec_ITIL4.pptx
@@ -117,19 +117,19 @@
   <p:extLst>
     <p:ext uri="{521415D9-36F7-43E2-AB2F-B90AF26B5E84}">
       <p14:sectionLst xmlns:p14="http://schemas.microsoft.com/office/powerpoint/2010/main">
-        <p14:section name="Introducción" id="{4677f556-d0c6-0b62-d44c-97599d528931}">
+        <p14:section name="Introducción" id="{2921264c-c447-18b4-903a-205ed01f9a55}">
           <p14:sldIdLst>
             <p14:sldId id="256"/>
             <p14:sldId id="257"/>
           </p14:sldIdLst>
         </p14:section>
-        <p14:section name="Diagnóstico" id="{0654e180-d99b-3fed-c504-10764ebac4e8}">
+        <p14:section name="Diagnóstico" id="{55673ce4-274c-cbc4-95bc-0e879919bad9}">
           <p14:sldIdLst>
             <p14:sldId id="258"/>
             <p14:sldId id="259"/>
           </p14:sldIdLst>
         </p14:section>
-        <p14:section name="Los 7 principios" id="{37498849-4df4-65d0-fda2-edf641f1b6ca}">
+        <p14:section name="Los 7 principios" id="{edfd30b2-1342-bfab-9f07-a6f9c281af0f}">
           <p14:sldIdLst>
             <p14:sldId id="260"/>
             <p14:sldId id="261"/>
@@ -137,13 +137,13 @@
             <p14:sldId id="263"/>
           </p14:sldIdLst>
         </p14:section>
-        <p14:section name="Propuesta" id="{67e9fc97-4bbe-5545-699e-70cbbb4fde24}">
+        <p14:section name="Propuesta" id="{efbe40a8-4986-42b4-1007-8e510b32d392}">
           <p14:sldIdLst>
             <p14:sldId id="264"/>
             <p14:sldId id="265"/>
           </p14:sldIdLst>
         </p14:section>
-        <p14:section name="Cierre" id="{61f88be0-8da9-f79b-bdd8-abf98edcc3ed}">
+        <p14:section name="Cierre" id="{bd020b24-7763-d97f-9ade-c16671a52c60}">
           <p14:sldIdLst>
             <p14:sldId id="266"/>
           </p14:sldIdLst>
@@ -1785,7 +1785,7 @@
                   <a:schemeClr val="accent6"/>
                 </a:solidFill>
               </a:rPr>
-              <a:t>Caso Innovatec · Principios orientadores ITIL 4</a:t>
+              <a:t>Caso Innovatec</a:t>
             </a:r>
             <a:endParaRPr lang="en-US" sz="900" dirty="0"/>
           </a:p>
@@ -2217,7 +2217,7 @@
                   <a:schemeClr val="accent2"/>
                 </a:solidFill>
               </a:rPr>
-              <a:t>CASO PRÁCTICO · GESTIÓN DE SERVICIOS TI</a:t>
+              <a:t>CASO PRÁCTICO</a:t>
             </a:r>
             <a:endParaRPr lang="en-US" sz="1200" dirty="0"/>
           </a:p>
@@ -2301,7 +2301,80 @@
       </p:sp>
       <p:sp>
         <p:nvSpPr>
-          <p:cNvPr id="5" name="halo"/>
+          <p:cNvPr id="5" name="author info"/>
+          <p:cNvSpPr txBox="1"/>
+          <p:nvPr/>
+        </p:nvSpPr>
+        <p:spPr>
+          <a:xfrm>
+            <a:off x="548640" y="4069080"/>
+            <a:ext cx="4937760" cy="777240"/>
+          </a:xfrm>
+          <a:prstGeom prst="rect">
+            <a:avLst/>
+          </a:prstGeom>
+          <a:noFill/>
+          <a:ln/>
+        </p:spPr>
+        <p:txBody>
+          <a:bodyPr wrap="square" lIns="0" tIns="0" rIns="0" bIns="0" rtlCol="0" anchor="t"/>
+          <a:lstStyle/>
+          <a:p>
+            <a:pPr indent="0" marL="0">
+              <a:spcAft>
+                <a:spcPts val="200"/>
+              </a:spcAft>
+              <a:buNone/>
+            </a:pPr>
+            <a:r>
+              <a:rPr lang="en-US" sz="1400" b="1" dirty="0">
+                <a:solidFill>
+                  <a:schemeClr val="bg1"/>
+                </a:solidFill>
+              </a:rPr>
+              <a:t>Nils Alexander Tovar Pinzón</a:t>
+            </a:r>
+            <a:endParaRPr lang="en-US" sz="1400" dirty="0"/>
+          </a:p>
+          <a:p>
+            <a:pPr indent="0" marL="0">
+              <a:spcAft>
+                <a:spcPts val="200"/>
+              </a:spcAft>
+              <a:buNone/>
+            </a:pPr>
+            <a:r>
+              <a:rPr lang="en-US" sz="1200" dirty="0">
+                <a:solidFill>
+                  <a:schemeClr val="bg2"/>
+                </a:solidFill>
+              </a:rPr>
+              <a:t>IV CICLO - SECCIÓN B</a:t>
+            </a:r>
+            <a:endParaRPr lang="en-US" sz="1400" dirty="0"/>
+          </a:p>
+          <a:p>
+            <a:pPr indent="0" marL="0">
+              <a:spcAft>
+                <a:spcPts val="200"/>
+              </a:spcAft>
+              <a:buNone/>
+            </a:pPr>
+            <a:r>
+              <a:rPr lang="en-US" sz="1200" dirty="0">
+                <a:solidFill>
+                  <a:schemeClr val="accent2"/>
+                </a:solidFill>
+              </a:rPr>
+              <a:t>GESTIÓN DE SERVICIOS TI - ZANDI MALLQU</a:t>
+            </a:r>
+            <a:endParaRPr lang="en-US" sz="1400" dirty="0"/>
+          </a:p>
+        </p:txBody>
+      </p:sp>
+      <p:sp>
+        <p:nvSpPr>
+          <p:cNvPr id="6" name="halo"/>
           <p:cNvSpPr/>
           <p:nvPr/>
         </p:nvSpPr>
@@ -2323,7 +2396,7 @@
       </p:sp>
       <p:sp>
         <p:nvSpPr>
-          <p:cNvPr id="6" name="Mesa de ayuda circle"/>
+          <p:cNvPr id="7" name="Mesa de ayuda circle"/>
           <p:cNvSpPr/>
           <p:nvPr/>
         </p:nvSpPr>
@@ -2343,7 +2416,7 @@
       </p:sp>
       <p:pic>
         <p:nvPicPr>
-          <p:cNvPr id="7" name="Mesa de ayuda icon" descr="Mesa de ayuda">    </p:cNvPr>
+          <p:cNvPr id="8" name="Mesa de ayuda icon" descr="Mesa de ayuda">    </p:cNvPr>
           <p:cNvPicPr>
             <a:picLocks noChangeAspect="1"/>
           </p:cNvPicPr>
@@ -2367,7 +2440,7 @@
       </p:pic>
       <p:sp>
         <p:nvSpPr>
-          <p:cNvPr id="8" name="Estudiante circle"/>
+          <p:cNvPr id="9" name="Estudiante circle"/>
           <p:cNvSpPr/>
           <p:nvPr/>
         </p:nvSpPr>
@@ -2387,7 +2460,7 @@
       </p:sp>
       <p:pic>
         <p:nvPicPr>
-          <p:cNvPr id="9" name="Estudiante icon" descr="Estudiante">    </p:cNvPr>
+          <p:cNvPr id="10" name="Estudiante icon" descr="Estudiante">    </p:cNvPr>
           <p:cNvPicPr>
             <a:picLocks noChangeAspect="1"/>
           </p:cNvPicPr>
@@ -2411,7 +2484,7 @@
       </p:pic>
       <p:sp>
         <p:nvSpPr>
-          <p:cNvPr id="10" name="Docente circle"/>
+          <p:cNvPr id="11" name="Docente circle"/>
           <p:cNvSpPr/>
           <p:nvPr/>
         </p:nvSpPr>
@@ -2431,7 +2504,7 @@
       </p:sp>
       <p:pic>
         <p:nvPicPr>
-          <p:cNvPr id="11" name="Docente icon" descr="Docente">    </p:cNvPr>
+          <p:cNvPr id="12" name="Docente icon" descr="Docente">    </p:cNvPr>
           <p:cNvPicPr>
             <a:picLocks noChangeAspect="1"/>
           </p:cNvPicPr>
@@ -2455,7 +2528,7 @@
       </p:pic>
       <p:sp>
         <p:nvSpPr>
-          <p:cNvPr id="12" name="Ticket circle"/>
+          <p:cNvPr id="13" name="Ticket circle"/>
           <p:cNvSpPr/>
           <p:nvPr/>
         </p:nvSpPr>
@@ -2475,7 +2548,7 @@
       </p:sp>
       <p:pic>
         <p:nvPicPr>
-          <p:cNvPr id="13" name="Ticket icon" descr="Ticket">    </p:cNvPr>
+          <p:cNvPr id="14" name="Ticket icon" descr="Ticket">    </p:cNvPr>
           <p:cNvPicPr>
             <a:picLocks noChangeAspect="1"/>
           </p:cNvPicPr>
@@ -2499,7 +2572,7 @@
       </p:pic>
       <p:sp>
         <p:nvSpPr>
-          <p:cNvPr id="14" name="Solución circle"/>
+          <p:cNvPr id="15" name="Solución circle"/>
           <p:cNvSpPr/>
           <p:nvPr/>
         </p:nvSpPr>
@@ -2519,7 +2592,7 @@
       </p:sp>
       <p:pic>
         <p:nvPicPr>
-          <p:cNvPr id="15" name="Solución icon" descr="Solución">    </p:cNvPr>
+          <p:cNvPr id="16" name="Solución icon" descr="Solución">    </p:cNvPr>
           <p:cNvPicPr>
             <a:picLocks noChangeAspect="1"/>
           </p:cNvPicPr>

</xml_diff>